<commit_message>
otros cambios mas en las diapositivas
</commit_message>
<xml_diff>
--- a/Apoyos/diapositivas para la presentacion.pptx
+++ b/Apoyos/diapositivas para la presentacion.pptx
@@ -15152,7 +15152,7 @@
         </p:blipFill>
         <p:spPr bwMode="auto">
           <a:xfrm>
-            <a:off x="6420329" y="1772129"/>
+            <a:off x="6420329" y="233223"/>
             <a:ext cx="5486242" cy="3418515"/>
           </a:xfrm>
           <a:prstGeom prst="rect">
@@ -15168,6 +15168,36 @@
               </a14:hiddenFill>
             </a:ext>
           </a:extLst>
+        </p:spPr>
+      </p:pic>
+      <p:pic>
+        <p:nvPicPr>
+          <p:cNvPr id="3" name="Imagen 2">
+            <a:extLst>
+              <a:ext uri="{FF2B5EF4-FFF2-40B4-BE49-F238E27FC236}">
+                <a16:creationId xmlns:a16="http://schemas.microsoft.com/office/drawing/2014/main" id="{653862D9-CE9A-C106-53AF-88B66B75E0A9}"/>
+              </a:ext>
+            </a:extLst>
+          </p:cNvPr>
+          <p:cNvPicPr>
+            <a:picLocks noChangeAspect="1"/>
+          </p:cNvPicPr>
+          <p:nvPr/>
+        </p:nvPicPr>
+        <p:blipFill>
+          <a:blip r:embed="rId7"/>
+          <a:stretch>
+            <a:fillRect/>
+          </a:stretch>
+        </p:blipFill>
+        <p:spPr>
+          <a:xfrm>
+            <a:off x="6410618" y="3884961"/>
+            <a:ext cx="5200357" cy="2583257"/>
+          </a:xfrm>
+          <a:prstGeom prst="rect">
+            <a:avLst/>
+          </a:prstGeom>
         </p:spPr>
       </p:pic>
     </p:spTree>
@@ -15245,7 +15275,7 @@
         </p:blipFill>
         <p:spPr>
           <a:xfrm>
-            <a:off x="3045083" y="1828800"/>
+            <a:off x="162183" y="2113688"/>
             <a:ext cx="6160889" cy="3467100"/>
           </a:xfrm>
           <a:prstGeom prst="rect">
@@ -15315,7 +15345,7 @@
         </p:nvSpPr>
         <p:spPr>
           <a:xfrm>
-            <a:off x="3492105" y="2152650"/>
+            <a:off x="609205" y="2437538"/>
             <a:ext cx="5828853" cy="276225"/>
           </a:xfrm>
           <a:prstGeom prst="rect">
@@ -15389,7 +15419,7 @@
         </p:nvSpPr>
         <p:spPr>
           <a:xfrm>
-            <a:off x="3492105" y="2571750"/>
+            <a:off x="609205" y="2856638"/>
             <a:ext cx="5551289" cy="304800"/>
           </a:xfrm>
           <a:prstGeom prst="rect">
@@ -15574,7 +15604,7 @@
         </p:nvSpPr>
         <p:spPr>
           <a:xfrm>
-            <a:off x="3873105" y="3067050"/>
+            <a:off x="990205" y="3351938"/>
             <a:ext cx="5170289" cy="304800"/>
           </a:xfrm>
           <a:prstGeom prst="rect">
@@ -15723,7 +15753,7 @@
         </p:nvSpPr>
         <p:spPr>
           <a:xfrm>
-            <a:off x="3873105" y="3562350"/>
+            <a:off x="990205" y="3847238"/>
             <a:ext cx="5170289" cy="304800"/>
           </a:xfrm>
           <a:prstGeom prst="rect">
@@ -15848,7 +15878,7 @@
         </p:nvSpPr>
         <p:spPr>
           <a:xfrm>
-            <a:off x="3873105" y="4057650"/>
+            <a:off x="990205" y="4342538"/>
             <a:ext cx="5170289" cy="304800"/>
           </a:xfrm>
           <a:prstGeom prst="rect">
@@ -15997,7 +16027,7 @@
         </p:nvSpPr>
         <p:spPr>
           <a:xfrm>
-            <a:off x="3851123" y="4475246"/>
+            <a:off x="968223" y="4760134"/>
             <a:ext cx="5170289" cy="369332"/>
           </a:xfrm>
           <a:prstGeom prst="rect">
@@ -16249,7 +16279,7 @@
         </p:blipFill>
         <p:spPr>
           <a:xfrm>
-            <a:off x="3505922" y="3148012"/>
+            <a:off x="623022" y="3432900"/>
             <a:ext cx="190500" cy="200025"/>
           </a:xfrm>
           <a:prstGeom prst="rect">
@@ -16276,7 +16306,7 @@
         </p:blipFill>
         <p:spPr>
           <a:xfrm>
-            <a:off x="3492105" y="3562350"/>
+            <a:off x="609205" y="3847238"/>
             <a:ext cx="190500" cy="200025"/>
           </a:xfrm>
           <a:prstGeom prst="rect">
@@ -16303,7 +16333,7 @@
         </p:blipFill>
         <p:spPr>
           <a:xfrm>
-            <a:off x="3492105" y="4057650"/>
+            <a:off x="609205" y="4342538"/>
             <a:ext cx="190500" cy="200025"/>
           </a:xfrm>
           <a:prstGeom prst="rect">
@@ -16330,7 +16360,7 @@
         </p:blipFill>
         <p:spPr>
           <a:xfrm>
-            <a:off x="3492105" y="4552950"/>
+            <a:off x="609205" y="4837838"/>
             <a:ext cx="190500" cy="200025"/>
           </a:xfrm>
           <a:prstGeom prst="rect">
@@ -16340,6 +16370,65 @@
           <a:ln>
             <a:noFill/>
           </a:ln>
+        </p:spPr>
+      </p:pic>
+      <p:pic>
+        <p:nvPicPr>
+          <p:cNvPr id="3" name="Imagen 2">
+            <a:extLst>
+              <a:ext uri="{FF2B5EF4-FFF2-40B4-BE49-F238E27FC236}">
+                <a16:creationId xmlns:a16="http://schemas.microsoft.com/office/drawing/2014/main" id="{1FB5C425-1FC9-9B9C-F976-378A7F76AEB7}"/>
+              </a:ext>
+            </a:extLst>
+          </p:cNvPr>
+          <p:cNvPicPr>
+            <a:picLocks noChangeAspect="1"/>
+          </p:cNvPicPr>
+          <p:nvPr/>
+        </p:nvPicPr>
+        <p:blipFill>
+          <a:blip r:embed="rId6"/>
+          <a:srcRect l="24141"/>
+          <a:stretch/>
+        </p:blipFill>
+        <p:spPr>
+          <a:xfrm>
+            <a:off x="6580782" y="1292586"/>
+            <a:ext cx="5449035" cy="2226453"/>
+          </a:xfrm>
+          <a:prstGeom prst="rect">
+            <a:avLst/>
+          </a:prstGeom>
+        </p:spPr>
+      </p:pic>
+      <p:pic>
+        <p:nvPicPr>
+          <p:cNvPr id="17" name="Imagen 16">
+            <a:extLst>
+              <a:ext uri="{FF2B5EF4-FFF2-40B4-BE49-F238E27FC236}">
+                <a16:creationId xmlns:a16="http://schemas.microsoft.com/office/drawing/2014/main" id="{5102F291-1EBC-B9FD-4E14-BD23F17B0CAE}"/>
+              </a:ext>
+            </a:extLst>
+          </p:cNvPr>
+          <p:cNvPicPr>
+            <a:picLocks noChangeAspect="1"/>
+          </p:cNvPicPr>
+          <p:nvPr/>
+        </p:nvPicPr>
+        <p:blipFill>
+          <a:blip r:embed="rId7"/>
+          <a:stretch>
+            <a:fillRect/>
+          </a:stretch>
+        </p:blipFill>
+        <p:spPr>
+          <a:xfrm>
+            <a:off x="6580782" y="3752911"/>
+            <a:ext cx="3972479" cy="2753109"/>
+          </a:xfrm>
+          <a:prstGeom prst="rect">
+            <a:avLst/>
+          </a:prstGeom>
         </p:spPr>
       </p:pic>
     </p:spTree>
@@ -21766,8 +21855,8 @@
         </p:blipFill>
         <p:spPr>
           <a:xfrm>
-            <a:off x="674935" y="1358051"/>
-            <a:ext cx="9270004" cy="2315591"/>
+            <a:off x="305276" y="1658304"/>
+            <a:ext cx="6456636" cy="1612829"/>
           </a:xfrm>
           <a:prstGeom prst="rect">
             <a:avLst/>
@@ -21788,8 +21877,8 @@
         </p:nvSpPr>
         <p:spPr>
           <a:xfrm>
-            <a:off x="674935" y="3928754"/>
-            <a:ext cx="10474328" cy="787908"/>
+            <a:off x="7551339" y="1562129"/>
+            <a:ext cx="4104484" cy="1969770"/>
           </a:xfrm>
           <a:prstGeom prst="rect">
             <a:avLst/>
@@ -21833,6 +21922,66 @@
           </a:p>
         </p:txBody>
       </p:sp>
+      <p:pic>
+        <p:nvPicPr>
+          <p:cNvPr id="5" name="Imagen 4">
+            <a:extLst>
+              <a:ext uri="{FF2B5EF4-FFF2-40B4-BE49-F238E27FC236}">
+                <a16:creationId xmlns:a16="http://schemas.microsoft.com/office/drawing/2014/main" id="{88FC6584-2976-451A-A47D-FC1B3FE2E0AA}"/>
+              </a:ext>
+            </a:extLst>
+          </p:cNvPr>
+          <p:cNvPicPr>
+            <a:picLocks noChangeAspect="1"/>
+          </p:cNvPicPr>
+          <p:nvPr/>
+        </p:nvPicPr>
+        <p:blipFill>
+          <a:blip r:embed="rId4"/>
+          <a:stretch>
+            <a:fillRect/>
+          </a:stretch>
+        </p:blipFill>
+        <p:spPr>
+          <a:xfrm>
+            <a:off x="4208464" y="4238533"/>
+            <a:ext cx="3557016" cy="2134210"/>
+          </a:xfrm>
+          <a:prstGeom prst="rect">
+            <a:avLst/>
+          </a:prstGeom>
+        </p:spPr>
+      </p:pic>
+      <p:pic>
+        <p:nvPicPr>
+          <p:cNvPr id="7" name="Imagen 6">
+            <a:extLst>
+              <a:ext uri="{FF2B5EF4-FFF2-40B4-BE49-F238E27FC236}">
+                <a16:creationId xmlns:a16="http://schemas.microsoft.com/office/drawing/2014/main" id="{A89A574D-6A51-1ABF-8CF3-2A778949021B}"/>
+              </a:ext>
+            </a:extLst>
+          </p:cNvPr>
+          <p:cNvPicPr>
+            <a:picLocks noChangeAspect="1"/>
+          </p:cNvPicPr>
+          <p:nvPr/>
+        </p:nvPicPr>
+        <p:blipFill>
+          <a:blip r:embed="rId5"/>
+          <a:stretch>
+            <a:fillRect/>
+          </a:stretch>
+        </p:blipFill>
+        <p:spPr>
+          <a:xfrm>
+            <a:off x="179561" y="4238533"/>
+            <a:ext cx="3651776" cy="2130203"/>
+          </a:xfrm>
+          <a:prstGeom prst="rect">
+            <a:avLst/>
+          </a:prstGeom>
+        </p:spPr>
+      </p:pic>
     </p:spTree>
     <p:extLst>
       <p:ext uri="{BB962C8B-B14F-4D97-AF65-F5344CB8AC3E}">

</xml_diff>